<commit_message>
1 Update project files
</commit_message>
<xml_diff>
--- a/Biobank_Management_System_Professional.pptx
+++ b/Biobank_Management_System_Professional.pptx
@@ -133,6 +133,210 @@
     </p:ext>
   </p:extLst>
 </p:presentation>
+</file>
+
+<file path=ppt/changesInfos/changesInfo1.xml><?xml version="1.0" encoding="utf-8"?>
+<pc:chgInfo xmlns:a="http://schemas.openxmlformats.org/drawingml/2006/main" xmlns:r="http://schemas.openxmlformats.org/officeDocument/2006/relationships" xmlns:ac="http://schemas.microsoft.com/office/drawing/2013/main/command" xmlns:pc="http://schemas.microsoft.com/office/powerpoint/2013/main/command">
+  <pc:docChgLst>
+    <pc:chgData name="lamiaa ayman" userId="91d975b727bceb9e" providerId="LiveId" clId="{59F8FAC7-ABC6-46D8-8C34-446CD13A0CD7}"/>
+    <pc:docChg chg="modSld">
+      <pc:chgData name="lamiaa ayman" userId="91d975b727bceb9e" providerId="LiveId" clId="{59F8FAC7-ABC6-46D8-8C34-446CD13A0CD7}" dt="2026-08-15T18:32:49.280" v="100" actId="1076"/>
+      <pc:docMkLst>
+        <pc:docMk/>
+      </pc:docMkLst>
+      <pc:sldChg chg="addSp modSp mod">
+        <pc:chgData name="lamiaa ayman" userId="91d975b727bceb9e" providerId="LiveId" clId="{59F8FAC7-ABC6-46D8-8C34-446CD13A0CD7}" dt="2026-08-15T18:24:36.684" v="17" actId="14100"/>
+        <pc:sldMkLst>
+          <pc:docMk/>
+          <pc:sldMk cId="0" sldId="266"/>
+        </pc:sldMkLst>
+        <pc:picChg chg="add mod">
+          <ac:chgData name="lamiaa ayman" userId="91d975b727bceb9e" providerId="LiveId" clId="{59F8FAC7-ABC6-46D8-8C34-446CD13A0CD7}" dt="2026-08-15T18:24:19.401" v="15" actId="1440"/>
+          <ac:picMkLst>
+            <pc:docMk/>
+            <pc:sldMk cId="0" sldId="266"/>
+            <ac:picMk id="10" creationId="{1D1CB914-C6B8-2CE4-1580-6DD45371E87D}"/>
+          </ac:picMkLst>
+        </pc:picChg>
+        <pc:picChg chg="mod">
+          <ac:chgData name="lamiaa ayman" userId="91d975b727bceb9e" providerId="LiveId" clId="{59F8FAC7-ABC6-46D8-8C34-446CD13A0CD7}" dt="2026-08-15T18:24:36.684" v="17" actId="14100"/>
+          <ac:picMkLst>
+            <pc:docMk/>
+            <pc:sldMk cId="0" sldId="266"/>
+            <ac:picMk id="31" creationId="{0242EB95-3AB5-47CD-7559-C1B2E1045DA7}"/>
+          </ac:picMkLst>
+        </pc:picChg>
+      </pc:sldChg>
+      <pc:sldChg chg="modSp mod">
+        <pc:chgData name="lamiaa ayman" userId="91d975b727bceb9e" providerId="LiveId" clId="{59F8FAC7-ABC6-46D8-8C34-446CD13A0CD7}" dt="2026-08-15T18:32:49.280" v="100" actId="1076"/>
+        <pc:sldMkLst>
+          <pc:docMk/>
+          <pc:sldMk cId="0" sldId="267"/>
+        </pc:sldMkLst>
+        <pc:spChg chg="mod">
+          <ac:chgData name="lamiaa ayman" userId="91d975b727bceb9e" providerId="LiveId" clId="{59F8FAC7-ABC6-46D8-8C34-446CD13A0CD7}" dt="2026-08-15T18:25:19.781" v="25" actId="1076"/>
+          <ac:spMkLst>
+            <pc:docMk/>
+            <pc:sldMk cId="0" sldId="267"/>
+            <ac:spMk id="8" creationId="{00000000-0000-0000-0000-000000000000}"/>
+          </ac:spMkLst>
+        </pc:spChg>
+        <pc:spChg chg="mod">
+          <ac:chgData name="lamiaa ayman" userId="91d975b727bceb9e" providerId="LiveId" clId="{59F8FAC7-ABC6-46D8-8C34-446CD13A0CD7}" dt="2026-08-15T18:25:37.572" v="28" actId="255"/>
+          <ac:spMkLst>
+            <pc:docMk/>
+            <pc:sldMk cId="0" sldId="267"/>
+            <ac:spMk id="11" creationId="{00000000-0000-0000-0000-000000000000}"/>
+          </ac:spMkLst>
+        </pc:spChg>
+        <pc:spChg chg="mod">
+          <ac:chgData name="lamiaa ayman" userId="91d975b727bceb9e" providerId="LiveId" clId="{59F8FAC7-ABC6-46D8-8C34-446CD13A0CD7}" dt="2026-08-15T18:25:25.544" v="26" actId="1076"/>
+          <ac:spMkLst>
+            <pc:docMk/>
+            <pc:sldMk cId="0" sldId="267"/>
+            <ac:spMk id="12" creationId="{00000000-0000-0000-0000-000000000000}"/>
+          </ac:spMkLst>
+        </pc:spChg>
+        <pc:spChg chg="mod">
+          <ac:chgData name="lamiaa ayman" userId="91d975b727bceb9e" providerId="LiveId" clId="{59F8FAC7-ABC6-46D8-8C34-446CD13A0CD7}" dt="2026-08-15T18:26:19.444" v="37" actId="1076"/>
+          <ac:spMkLst>
+            <pc:docMk/>
+            <pc:sldMk cId="0" sldId="267"/>
+            <ac:spMk id="17" creationId="{00000000-0000-0000-0000-000000000000}"/>
+          </ac:spMkLst>
+        </pc:spChg>
+        <pc:spChg chg="mod">
+          <ac:chgData name="lamiaa ayman" userId="91d975b727bceb9e" providerId="LiveId" clId="{59F8FAC7-ABC6-46D8-8C34-446CD13A0CD7}" dt="2026-08-15T18:27:05.903" v="47" actId="20577"/>
+          <ac:spMkLst>
+            <pc:docMk/>
+            <pc:sldMk cId="0" sldId="267"/>
+            <ac:spMk id="18" creationId="{00000000-0000-0000-0000-000000000000}"/>
+          </ac:spMkLst>
+        </pc:spChg>
+        <pc:spChg chg="mod">
+          <ac:chgData name="lamiaa ayman" userId="91d975b727bceb9e" providerId="LiveId" clId="{59F8FAC7-ABC6-46D8-8C34-446CD13A0CD7}" dt="2026-08-15T18:26:30.255" v="38" actId="255"/>
+          <ac:spMkLst>
+            <pc:docMk/>
+            <pc:sldMk cId="0" sldId="267"/>
+            <ac:spMk id="23" creationId="{00000000-0000-0000-0000-000000000000}"/>
+          </ac:spMkLst>
+        </pc:spChg>
+        <pc:spChg chg="mod">
+          <ac:chgData name="lamiaa ayman" userId="91d975b727bceb9e" providerId="LiveId" clId="{59F8FAC7-ABC6-46D8-8C34-446CD13A0CD7}" dt="2026-08-15T18:27:00.600" v="46" actId="14100"/>
+          <ac:spMkLst>
+            <pc:docMk/>
+            <pc:sldMk cId="0" sldId="267"/>
+            <ac:spMk id="24" creationId="{00000000-0000-0000-0000-000000000000}"/>
+          </ac:spMkLst>
+        </pc:spChg>
+        <pc:spChg chg="mod">
+          <ac:chgData name="lamiaa ayman" userId="91d975b727bceb9e" providerId="LiveId" clId="{59F8FAC7-ABC6-46D8-8C34-446CD13A0CD7}" dt="2026-08-15T18:28:10.017" v="54" actId="255"/>
+          <ac:spMkLst>
+            <pc:docMk/>
+            <pc:sldMk cId="0" sldId="267"/>
+            <ac:spMk id="29" creationId="{00000000-0000-0000-0000-000000000000}"/>
+          </ac:spMkLst>
+        </pc:spChg>
+        <pc:spChg chg="mod">
+          <ac:chgData name="lamiaa ayman" userId="91d975b727bceb9e" providerId="LiveId" clId="{59F8FAC7-ABC6-46D8-8C34-446CD13A0CD7}" dt="2026-08-15T18:28:14.646" v="55" actId="1076"/>
+          <ac:spMkLst>
+            <pc:docMk/>
+            <pc:sldMk cId="0" sldId="267"/>
+            <ac:spMk id="30" creationId="{00000000-0000-0000-0000-000000000000}"/>
+          </ac:spMkLst>
+        </pc:spChg>
+        <pc:spChg chg="mod">
+          <ac:chgData name="lamiaa ayman" userId="91d975b727bceb9e" providerId="LiveId" clId="{59F8FAC7-ABC6-46D8-8C34-446CD13A0CD7}" dt="2026-08-15T18:28:23.752" v="56" actId="255"/>
+          <ac:spMkLst>
+            <pc:docMk/>
+            <pc:sldMk cId="0" sldId="267"/>
+            <ac:spMk id="35" creationId="{00000000-0000-0000-0000-000000000000}"/>
+          </ac:spMkLst>
+        </pc:spChg>
+        <pc:spChg chg="mod">
+          <ac:chgData name="lamiaa ayman" userId="91d975b727bceb9e" providerId="LiveId" clId="{59F8FAC7-ABC6-46D8-8C34-446CD13A0CD7}" dt="2026-08-15T18:28:48.291" v="61" actId="207"/>
+          <ac:spMkLst>
+            <pc:docMk/>
+            <pc:sldMk cId="0" sldId="267"/>
+            <ac:spMk id="36" creationId="{00000000-0000-0000-0000-000000000000}"/>
+          </ac:spMkLst>
+        </pc:spChg>
+        <pc:spChg chg="mod">
+          <ac:chgData name="lamiaa ayman" userId="91d975b727bceb9e" providerId="LiveId" clId="{59F8FAC7-ABC6-46D8-8C34-446CD13A0CD7}" dt="2026-08-15T18:29:38.645" v="69" actId="255"/>
+          <ac:spMkLst>
+            <pc:docMk/>
+            <pc:sldMk cId="0" sldId="267"/>
+            <ac:spMk id="41" creationId="{00000000-0000-0000-0000-000000000000}"/>
+          </ac:spMkLst>
+        </pc:spChg>
+        <pc:spChg chg="mod">
+          <ac:chgData name="lamiaa ayman" userId="91d975b727bceb9e" providerId="LiveId" clId="{59F8FAC7-ABC6-46D8-8C34-446CD13A0CD7}" dt="2026-08-15T18:29:32.791" v="68" actId="1076"/>
+          <ac:spMkLst>
+            <pc:docMk/>
+            <pc:sldMk cId="0" sldId="267"/>
+            <ac:spMk id="42" creationId="{00000000-0000-0000-0000-000000000000}"/>
+          </ac:spMkLst>
+        </pc:spChg>
+        <pc:spChg chg="mod">
+          <ac:chgData name="lamiaa ayman" userId="91d975b727bceb9e" providerId="LiveId" clId="{59F8FAC7-ABC6-46D8-8C34-446CD13A0CD7}" dt="2026-08-15T18:30:35.599" v="80" actId="255"/>
+          <ac:spMkLst>
+            <pc:docMk/>
+            <pc:sldMk cId="0" sldId="267"/>
+            <ac:spMk id="48" creationId="{00000000-0000-0000-0000-000000000000}"/>
+          </ac:spMkLst>
+        </pc:spChg>
+        <pc:spChg chg="mod">
+          <ac:chgData name="lamiaa ayman" userId="91d975b727bceb9e" providerId="LiveId" clId="{59F8FAC7-ABC6-46D8-8C34-446CD13A0CD7}" dt="2026-08-15T18:30:28.159" v="79" actId="1076"/>
+          <ac:spMkLst>
+            <pc:docMk/>
+            <pc:sldMk cId="0" sldId="267"/>
+            <ac:spMk id="49" creationId="{00000000-0000-0000-0000-000000000000}"/>
+          </ac:spMkLst>
+        </pc:spChg>
+        <pc:spChg chg="mod">
+          <ac:chgData name="lamiaa ayman" userId="91d975b727bceb9e" providerId="LiveId" clId="{59F8FAC7-ABC6-46D8-8C34-446CD13A0CD7}" dt="2026-08-15T18:30:46.126" v="81" actId="255"/>
+          <ac:spMkLst>
+            <pc:docMk/>
+            <pc:sldMk cId="0" sldId="267"/>
+            <ac:spMk id="54" creationId="{00000000-0000-0000-0000-000000000000}"/>
+          </ac:spMkLst>
+        </pc:spChg>
+        <pc:spChg chg="mod">
+          <ac:chgData name="lamiaa ayman" userId="91d975b727bceb9e" providerId="LiveId" clId="{59F8FAC7-ABC6-46D8-8C34-446CD13A0CD7}" dt="2026-08-15T18:31:31.437" v="89" actId="1076"/>
+          <ac:spMkLst>
+            <pc:docMk/>
+            <pc:sldMk cId="0" sldId="267"/>
+            <ac:spMk id="55" creationId="{00000000-0000-0000-0000-000000000000}"/>
+          </ac:spMkLst>
+        </pc:spChg>
+        <pc:spChg chg="mod">
+          <ac:chgData name="lamiaa ayman" userId="91d975b727bceb9e" providerId="LiveId" clId="{59F8FAC7-ABC6-46D8-8C34-446CD13A0CD7}" dt="2026-08-15T18:31:51.319" v="90" actId="1076"/>
+          <ac:spMkLst>
+            <pc:docMk/>
+            <pc:sldMk cId="0" sldId="267"/>
+            <ac:spMk id="56" creationId="{00000000-0000-0000-0000-000000000000}"/>
+          </ac:spMkLst>
+        </pc:spChg>
+        <pc:spChg chg="mod">
+          <ac:chgData name="lamiaa ayman" userId="91d975b727bceb9e" providerId="LiveId" clId="{59F8FAC7-ABC6-46D8-8C34-446CD13A0CD7}" dt="2026-08-15T18:32:35.145" v="98" actId="255"/>
+          <ac:spMkLst>
+            <pc:docMk/>
+            <pc:sldMk cId="0" sldId="267"/>
+            <ac:spMk id="60" creationId="{00000000-0000-0000-0000-000000000000}"/>
+          </ac:spMkLst>
+        </pc:spChg>
+        <pc:spChg chg="mod">
+          <ac:chgData name="lamiaa ayman" userId="91d975b727bceb9e" providerId="LiveId" clId="{59F8FAC7-ABC6-46D8-8C34-446CD13A0CD7}" dt="2026-08-15T18:32:49.280" v="100" actId="1076"/>
+          <ac:spMkLst>
+            <pc:docMk/>
+            <pc:sldMk cId="0" sldId="267"/>
+            <ac:spMk id="61" creationId="{00000000-0000-0000-0000-000000000000}"/>
+          </ac:spMkLst>
+        </pc:spChg>
+      </pc:sldChg>
+    </pc:docChg>
+  </pc:docChgLst>
+</pc:chgInfo>
 </file>
 
 <file path=ppt/slideLayouts/slideLayout1.xml><?xml version="1.0" encoding="utf-8"?>
@@ -12322,8 +12526,54 @@
         </p:blipFill>
         <p:spPr>
           <a:xfrm>
-            <a:off x="286512" y="1225296"/>
-            <a:ext cx="5684520" cy="3571488"/>
+            <a:off x="286512" y="1234440"/>
+            <a:ext cx="5669966" cy="3562344"/>
+          </a:xfrm>
+          <a:prstGeom prst="round2DiagRect">
+            <a:avLst>
+              <a:gd name="adj1" fmla="val 16667"/>
+              <a:gd name="adj2" fmla="val 1586"/>
+            </a:avLst>
+          </a:prstGeom>
+          <a:ln w="88900" cap="sq">
+            <a:solidFill>
+              <a:srgbClr val="FFFFFF"/>
+            </a:solidFill>
+            <a:miter lim="800000"/>
+          </a:ln>
+          <a:effectLst>
+            <a:outerShdw blurRad="254000" algn="tl" rotWithShape="0">
+              <a:srgbClr val="000000">
+                <a:alpha val="43000"/>
+              </a:srgbClr>
+            </a:outerShdw>
+          </a:effectLst>
+        </p:spPr>
+      </p:pic>
+      <p:pic>
+        <p:nvPicPr>
+          <p:cNvPr id="10" name="Picture 9">
+            <a:extLst>
+              <a:ext uri="{FF2B5EF4-FFF2-40B4-BE49-F238E27FC236}">
+                <a16:creationId xmlns:a16="http://schemas.microsoft.com/office/drawing/2014/main" id="{1D1CB914-C6B8-2CE4-1580-6DD45371E87D}"/>
+              </a:ext>
+            </a:extLst>
+          </p:cNvPr>
+          <p:cNvPicPr>
+            <a:picLocks noChangeAspect="1"/>
+          </p:cNvPicPr>
+          <p:nvPr/>
+        </p:nvPicPr>
+        <p:blipFill>
+          <a:blip r:embed="rId3"/>
+          <a:stretch>
+            <a:fillRect/>
+          </a:stretch>
+        </p:blipFill>
+        <p:spPr>
+          <a:xfrm>
+            <a:off x="6323076" y="1307597"/>
+            <a:ext cx="5487695" cy="3511291"/>
           </a:xfrm>
           <a:prstGeom prst="round2DiagRect">
             <a:avLst>
@@ -12597,7 +12847,7 @@
         </p:nvSpPr>
         <p:spPr>
           <a:xfrm>
-            <a:off x="502920" y="1417320"/>
+            <a:off x="521208" y="1438934"/>
             <a:ext cx="1719072" cy="1965960"/>
           </a:xfrm>
           <a:prstGeom prst="roundRect">
@@ -12724,8 +12974,8 @@
         </p:nvSpPr>
         <p:spPr>
           <a:xfrm>
-            <a:off x="658368" y="2084831"/>
-            <a:ext cx="1389888" cy="292608"/>
+            <a:off x="693504" y="2167128"/>
+            <a:ext cx="1374479" cy="270843"/>
           </a:xfrm>
           <a:prstGeom prst="rect">
             <a:avLst/>
@@ -12740,7 +12990,7 @@
           <a:p>
             <a:pPr algn="ctr"/>
             <a:r>
-              <a:rPr sz="1050" b="1" i="0">
+              <a:rPr sz="1400" b="1" i="0" dirty="0">
                 <a:solidFill>
                   <a:srgbClr val="0A0A0A"/>
                 </a:solidFill>
@@ -12759,8 +13009,8 @@
         </p:nvSpPr>
         <p:spPr>
           <a:xfrm>
-            <a:off x="667512" y="2487168"/>
-            <a:ext cx="1389888" cy="640080"/>
+            <a:off x="564663" y="2517695"/>
+            <a:ext cx="1698477" cy="563231"/>
           </a:xfrm>
           <a:prstGeom prst="rect">
             <a:avLst/>
@@ -12775,13 +13025,64 @@
           <a:p>
             <a:pPr algn="ctr"/>
             <a:r>
-              <a:rPr sz="819" b="0" i="0">
-                <a:solidFill>
-                  <a:srgbClr val="5F5F5F"/>
-                </a:solidFill>
-                <a:latin typeface="Aptos"/>
-              </a:rPr>
-              <a:t>Define entities, attributes and business rules.</a:t>
+              <a:rPr sz="1100" b="1" i="0" dirty="0">
+                <a:solidFill>
+                  <a:schemeClr val="tx1">
+                    <a:lumMod val="95000"/>
+                    <a:lumOff val="5000"/>
+                  </a:schemeClr>
+                </a:solidFill>
+                <a:latin typeface="Aptos"/>
+              </a:rPr>
+              <a:t>Define entities, attributes</a:t>
+            </a:r>
+            <a:endParaRPr lang="en-US" sz="1100" b="1" i="0" dirty="0">
+              <a:solidFill>
+                <a:schemeClr val="tx1">
+                  <a:lumMod val="95000"/>
+                  <a:lumOff val="5000"/>
+                </a:schemeClr>
+              </a:solidFill>
+              <a:latin typeface="Aptos"/>
+            </a:endParaRPr>
+          </a:p>
+          <a:p>
+            <a:pPr algn="ctr"/>
+            <a:r>
+              <a:rPr sz="1100" b="1" i="0" dirty="0">
+                <a:solidFill>
+                  <a:schemeClr val="tx1">
+                    <a:lumMod val="95000"/>
+                    <a:lumOff val="5000"/>
+                  </a:schemeClr>
+                </a:solidFill>
+                <a:latin typeface="Aptos"/>
+              </a:rPr>
+              <a:t> and</a:t>
+            </a:r>
+            <a:endParaRPr lang="en-US" sz="1100" b="1" i="0" dirty="0">
+              <a:solidFill>
+                <a:schemeClr val="tx1">
+                  <a:lumMod val="95000"/>
+                  <a:lumOff val="5000"/>
+                </a:schemeClr>
+              </a:solidFill>
+              <a:latin typeface="Aptos"/>
+            </a:endParaRPr>
+          </a:p>
+          <a:p>
+            <a:pPr algn="ctr"/>
+            <a:r>
+              <a:rPr sz="1100" b="1" i="0" dirty="0">
+                <a:solidFill>
+                  <a:schemeClr val="tx1">
+                    <a:lumMod val="95000"/>
+                    <a:lumOff val="5000"/>
+                  </a:schemeClr>
+                </a:solidFill>
+                <a:latin typeface="Aptos"/>
+              </a:rPr>
+              <a:t> business rules.</a:t>
             </a:r>
           </a:p>
         </p:txBody>
@@ -12956,8 +13257,8 @@
         </p:nvSpPr>
         <p:spPr>
           <a:xfrm>
-            <a:off x="2560320" y="2084831"/>
-            <a:ext cx="1389888" cy="292608"/>
+            <a:off x="2752343" y="2151071"/>
+            <a:ext cx="956287" cy="270843"/>
           </a:xfrm>
           <a:prstGeom prst="rect">
             <a:avLst/>
@@ -12972,7 +13273,7 @@
           <a:p>
             <a:pPr algn="ctr"/>
             <a:r>
-              <a:rPr sz="1050" b="1" i="0">
+              <a:rPr sz="1400" b="1" i="0" dirty="0">
                 <a:solidFill>
                   <a:srgbClr val="0A0A0A"/>
                 </a:solidFill>
@@ -12991,8 +13292,8 @@
         </p:nvSpPr>
         <p:spPr>
           <a:xfrm>
-            <a:off x="2569464" y="2487168"/>
-            <a:ext cx="1389888" cy="640080"/>
+            <a:off x="2648620" y="2577846"/>
+            <a:ext cx="1360244" cy="563231"/>
           </a:xfrm>
           <a:prstGeom prst="rect">
             <a:avLst/>
@@ -13007,13 +13308,64 @@
           <a:p>
             <a:pPr algn="ctr"/>
             <a:r>
-              <a:rPr sz="819" b="0" i="0">
-                <a:solidFill>
-                  <a:srgbClr val="5F5F5F"/>
-                </a:solidFill>
-                <a:latin typeface="Aptos"/>
-              </a:rPr>
-              <a:t>Model relationships and cardinalities.</a:t>
+              <a:rPr sz="1100" b="1" i="0" dirty="0">
+                <a:solidFill>
+                  <a:schemeClr val="tx1">
+                    <a:lumMod val="95000"/>
+                    <a:lumOff val="5000"/>
+                  </a:schemeClr>
+                </a:solidFill>
+                <a:latin typeface="Aptos"/>
+              </a:rPr>
+              <a:t>Model relationships </a:t>
+            </a:r>
+            <a:endParaRPr lang="en-US" sz="1100" b="1" i="0" dirty="0">
+              <a:solidFill>
+                <a:schemeClr val="tx1">
+                  <a:lumMod val="95000"/>
+                  <a:lumOff val="5000"/>
+                </a:schemeClr>
+              </a:solidFill>
+              <a:latin typeface="Aptos"/>
+            </a:endParaRPr>
+          </a:p>
+          <a:p>
+            <a:pPr algn="ctr"/>
+            <a:r>
+              <a:rPr sz="1100" b="1" i="0" dirty="0">
+                <a:solidFill>
+                  <a:schemeClr val="tx1">
+                    <a:lumMod val="95000"/>
+                    <a:lumOff val="5000"/>
+                  </a:schemeClr>
+                </a:solidFill>
+                <a:latin typeface="Aptos"/>
+              </a:rPr>
+              <a:t>and</a:t>
+            </a:r>
+            <a:endParaRPr lang="en-US" sz="1100" b="1" i="0" dirty="0">
+              <a:solidFill>
+                <a:schemeClr val="tx1">
+                  <a:lumMod val="95000"/>
+                  <a:lumOff val="5000"/>
+                </a:schemeClr>
+              </a:solidFill>
+              <a:latin typeface="Aptos"/>
+            </a:endParaRPr>
+          </a:p>
+          <a:p>
+            <a:pPr algn="ctr"/>
+            <a:r>
+              <a:rPr sz="1100" b="1" i="0" dirty="0">
+                <a:solidFill>
+                  <a:schemeClr val="tx1">
+                    <a:lumMod val="95000"/>
+                    <a:lumOff val="5000"/>
+                  </a:schemeClr>
+                </a:solidFill>
+                <a:latin typeface="Aptos"/>
+              </a:rPr>
+              <a:t> cardinalities.</a:t>
             </a:r>
           </a:p>
         </p:txBody>
@@ -13188,8 +13540,8 @@
         </p:nvSpPr>
         <p:spPr>
           <a:xfrm>
-            <a:off x="4462272" y="2084831"/>
-            <a:ext cx="1389888" cy="292608"/>
+            <a:off x="4586900" y="2084831"/>
+            <a:ext cx="1140632" cy="270843"/>
           </a:xfrm>
           <a:prstGeom prst="rect">
             <a:avLst/>
@@ -13204,7 +13556,7 @@
           <a:p>
             <a:pPr algn="ctr"/>
             <a:r>
-              <a:rPr sz="1050" b="1" i="0">
+              <a:rPr sz="1400" b="1" i="0" dirty="0">
                 <a:solidFill>
                   <a:srgbClr val="0A0A0A"/>
                 </a:solidFill>
@@ -13223,8 +13575,8 @@
         </p:nvSpPr>
         <p:spPr>
           <a:xfrm>
-            <a:off x="4471416" y="2487168"/>
-            <a:ext cx="1389888" cy="640080"/>
+            <a:off x="4498848" y="2551176"/>
+            <a:ext cx="1342498" cy="563231"/>
           </a:xfrm>
           <a:prstGeom prst="rect">
             <a:avLst/>
@@ -13232,20 +13584,71 @@
           <a:noFill/>
         </p:spPr>
         <p:txBody>
-          <a:bodyPr wrap="none" lIns="27432" tIns="27432" rIns="27432" bIns="27432" anchor="t">
+          <a:bodyPr wrap="square" lIns="27432" tIns="27432" rIns="27432" bIns="27432" anchor="t">
             <a:spAutoFit/>
           </a:bodyPr>
           <a:lstStyle/>
           <a:p>
             <a:pPr algn="ctr"/>
             <a:r>
-              <a:rPr sz="819" b="0" i="0">
-                <a:solidFill>
-                  <a:srgbClr val="5F5F5F"/>
-                </a:solidFill>
-                <a:latin typeface="Aptos"/>
-              </a:rPr>
-              <a:t>Map entities into normalized tables.</a:t>
+              <a:rPr sz="1100" b="1" i="0" dirty="0">
+                <a:solidFill>
+                  <a:schemeClr val="tx1">
+                    <a:lumMod val="95000"/>
+                    <a:lumOff val="5000"/>
+                  </a:schemeClr>
+                </a:solidFill>
+                <a:latin typeface="Aptos"/>
+              </a:rPr>
+              <a:t>Map entities</a:t>
+            </a:r>
+            <a:endParaRPr lang="en-US" sz="1100" b="1" i="0" dirty="0">
+              <a:solidFill>
+                <a:schemeClr val="tx1">
+                  <a:lumMod val="95000"/>
+                  <a:lumOff val="5000"/>
+                </a:schemeClr>
+              </a:solidFill>
+              <a:latin typeface="Aptos"/>
+            </a:endParaRPr>
+          </a:p>
+          <a:p>
+            <a:pPr algn="ctr"/>
+            <a:r>
+              <a:rPr sz="1100" b="1" i="0" dirty="0">
+                <a:solidFill>
+                  <a:schemeClr val="tx1">
+                    <a:lumMod val="95000"/>
+                    <a:lumOff val="5000"/>
+                  </a:schemeClr>
+                </a:solidFill>
+                <a:latin typeface="Aptos"/>
+              </a:rPr>
+              <a:t> into </a:t>
+            </a:r>
+            <a:endParaRPr lang="en-US" sz="1100" b="1" i="0" dirty="0">
+              <a:solidFill>
+                <a:schemeClr val="tx1">
+                  <a:lumMod val="95000"/>
+                  <a:lumOff val="5000"/>
+                </a:schemeClr>
+              </a:solidFill>
+              <a:latin typeface="Aptos"/>
+            </a:endParaRPr>
+          </a:p>
+          <a:p>
+            <a:pPr algn="ctr"/>
+            <a:r>
+              <a:rPr sz="1100" b="1" i="0" dirty="0">
+                <a:solidFill>
+                  <a:schemeClr val="tx1">
+                    <a:lumMod val="95000"/>
+                    <a:lumOff val="5000"/>
+                  </a:schemeClr>
+                </a:solidFill>
+                <a:latin typeface="Aptos"/>
+              </a:rPr>
+              <a:t>normalized tables.</a:t>
             </a:r>
           </a:p>
         </p:txBody>
@@ -13420,8 +13823,8 @@
         </p:nvSpPr>
         <p:spPr>
           <a:xfrm>
-            <a:off x="6364224" y="2084831"/>
-            <a:ext cx="1389888" cy="292608"/>
+            <a:off x="6741228" y="2084831"/>
+            <a:ext cx="635879" cy="270843"/>
           </a:xfrm>
           <a:prstGeom prst="rect">
             <a:avLst/>
@@ -13436,7 +13839,7 @@
           <a:p>
             <a:pPr algn="ctr"/>
             <a:r>
-              <a:rPr sz="1050" b="1" i="0">
+              <a:rPr sz="1400" b="1" i="0" dirty="0">
                 <a:solidFill>
                   <a:srgbClr val="0A0A0A"/>
                 </a:solidFill>
@@ -13455,8 +13858,8 @@
         </p:nvSpPr>
         <p:spPr>
           <a:xfrm>
-            <a:off x="6373368" y="2487168"/>
-            <a:ext cx="1389888" cy="640080"/>
+            <a:off x="6373368" y="2522982"/>
+            <a:ext cx="1450012" cy="393954"/>
           </a:xfrm>
           <a:prstGeom prst="rect">
             <a:avLst/>
@@ -13471,13 +13874,40 @@
           <a:p>
             <a:pPr algn="ctr"/>
             <a:r>
-              <a:rPr sz="819" b="0" i="0">
-                <a:solidFill>
-                  <a:srgbClr val="5F5F5F"/>
-                </a:solidFill>
-                <a:latin typeface="Aptos"/>
-              </a:rPr>
-              <a:t>Create tables, keys, constraints and data.</a:t>
+              <a:rPr sz="1100" b="1" i="0" dirty="0">
+                <a:solidFill>
+                  <a:schemeClr val="tx1">
+                    <a:lumMod val="95000"/>
+                    <a:lumOff val="5000"/>
+                  </a:schemeClr>
+                </a:solidFill>
+                <a:latin typeface="Aptos"/>
+              </a:rPr>
+              <a:t>Create tables, keys,</a:t>
+            </a:r>
+            <a:endParaRPr lang="en-US" sz="1100" b="1" i="0" dirty="0">
+              <a:solidFill>
+                <a:schemeClr val="tx1">
+                  <a:lumMod val="95000"/>
+                  <a:lumOff val="5000"/>
+                </a:schemeClr>
+              </a:solidFill>
+              <a:latin typeface="Aptos"/>
+            </a:endParaRPr>
+          </a:p>
+          <a:p>
+            <a:pPr algn="ctr"/>
+            <a:r>
+              <a:rPr sz="1100" b="1" i="0" dirty="0">
+                <a:solidFill>
+                  <a:schemeClr val="tx1">
+                    <a:lumMod val="95000"/>
+                    <a:lumOff val="5000"/>
+                  </a:schemeClr>
+                </a:solidFill>
+                <a:latin typeface="Aptos"/>
+              </a:rPr>
+              <a:t> constraints and data.</a:t>
             </a:r>
           </a:p>
         </p:txBody>
@@ -13652,8 +14082,8 @@
         </p:nvSpPr>
         <p:spPr>
           <a:xfrm>
-            <a:off x="8266176" y="2084831"/>
-            <a:ext cx="1389888" cy="292608"/>
+            <a:off x="8383814" y="2084831"/>
+            <a:ext cx="1154611" cy="270843"/>
           </a:xfrm>
           <a:prstGeom prst="rect">
             <a:avLst/>
@@ -13668,7 +14098,7 @@
           <a:p>
             <a:pPr algn="ctr"/>
             <a:r>
-              <a:rPr sz="1050" b="1" i="0">
+              <a:rPr sz="1400" b="1" i="0" dirty="0">
                 <a:solidFill>
                   <a:srgbClr val="0A0A0A"/>
                 </a:solidFill>
@@ -13687,8 +14117,8 @@
         </p:nvSpPr>
         <p:spPr>
           <a:xfrm>
-            <a:off x="8275320" y="2487168"/>
-            <a:ext cx="1389888" cy="640080"/>
+            <a:off x="8381513" y="2487168"/>
+            <a:ext cx="1177502" cy="393954"/>
           </a:xfrm>
           <a:prstGeom prst="rect">
             <a:avLst/>
@@ -13703,13 +14133,40 @@
           <a:p>
             <a:pPr algn="ctr"/>
             <a:r>
-              <a:rPr sz="819" b="0" i="0">
-                <a:solidFill>
-                  <a:srgbClr val="5F5F5F"/>
-                </a:solidFill>
-                <a:latin typeface="Aptos"/>
-              </a:rPr>
-              <a:t>Run queries, views and trigger.</a:t>
+              <a:rPr sz="1100" b="1" i="0" dirty="0">
+                <a:solidFill>
+                  <a:schemeClr val="tx1">
+                    <a:lumMod val="95000"/>
+                    <a:lumOff val="5000"/>
+                  </a:schemeClr>
+                </a:solidFill>
+                <a:latin typeface="Aptos"/>
+              </a:rPr>
+              <a:t>Run queries, </a:t>
+            </a:r>
+            <a:endParaRPr lang="en-US" sz="1100" b="1" i="0" dirty="0">
+              <a:solidFill>
+                <a:schemeClr val="tx1">
+                  <a:lumMod val="95000"/>
+                  <a:lumOff val="5000"/>
+                </a:schemeClr>
+              </a:solidFill>
+              <a:latin typeface="Aptos"/>
+            </a:endParaRPr>
+          </a:p>
+          <a:p>
+            <a:pPr algn="ctr"/>
+            <a:r>
+              <a:rPr sz="1100" b="1" i="0" dirty="0">
+                <a:solidFill>
+                  <a:schemeClr val="tx1">
+                    <a:lumMod val="95000"/>
+                    <a:lumOff val="5000"/>
+                  </a:schemeClr>
+                </a:solidFill>
+                <a:latin typeface="Aptos"/>
+              </a:rPr>
+              <a:t>views and trigger.</a:t>
             </a:r>
           </a:p>
         </p:txBody>
@@ -13884,8 +14341,8 @@
         </p:nvSpPr>
         <p:spPr>
           <a:xfrm>
-            <a:off x="10168128" y="2084831"/>
-            <a:ext cx="1389888" cy="292608"/>
+            <a:off x="10682285" y="2084831"/>
+            <a:ext cx="361574" cy="270843"/>
           </a:xfrm>
           <a:prstGeom prst="rect">
             <a:avLst/>
@@ -13900,7 +14357,7 @@
           <a:p>
             <a:pPr algn="ctr"/>
             <a:r>
-              <a:rPr sz="1050" b="1" i="0">
+              <a:rPr sz="1400" b="1" i="0" dirty="0">
                 <a:solidFill>
                   <a:srgbClr val="0A0A0A"/>
                 </a:solidFill>
@@ -13919,8 +14376,8 @@
         </p:nvSpPr>
         <p:spPr>
           <a:xfrm>
-            <a:off x="10177272" y="2487168"/>
-            <a:ext cx="1389888" cy="640080"/>
+            <a:off x="10266340" y="2495930"/>
+            <a:ext cx="1236812" cy="393954"/>
           </a:xfrm>
           <a:prstGeom prst="rect">
             <a:avLst/>
@@ -13935,13 +14392,64 @@
           <a:p>
             <a:pPr algn="ctr"/>
             <a:r>
-              <a:rPr sz="819" b="0" i="0">
-                <a:solidFill>
-                  <a:srgbClr val="5F5F5F"/>
-                </a:solidFill>
-                <a:latin typeface="Aptos"/>
-              </a:rPr>
-              <a:t>Connect Tkinter to the live database.</a:t>
+              <a:rPr sz="1100" b="1" i="0" dirty="0">
+                <a:solidFill>
+                  <a:schemeClr val="tx1">
+                    <a:lumMod val="95000"/>
+                    <a:lumOff val="5000"/>
+                  </a:schemeClr>
+                </a:solidFill>
+                <a:latin typeface="Aptos"/>
+              </a:rPr>
+              <a:t>Connect </a:t>
+            </a:r>
+            <a:r>
+              <a:rPr sz="1100" b="1" i="0" dirty="0" err="1">
+                <a:solidFill>
+                  <a:schemeClr val="tx1">
+                    <a:lumMod val="95000"/>
+                    <a:lumOff val="5000"/>
+                  </a:schemeClr>
+                </a:solidFill>
+                <a:latin typeface="Aptos"/>
+              </a:rPr>
+              <a:t>Tkinter</a:t>
+            </a:r>
+            <a:r>
+              <a:rPr sz="1100" b="1" i="0" dirty="0">
+                <a:solidFill>
+                  <a:schemeClr val="tx1">
+                    <a:lumMod val="95000"/>
+                    <a:lumOff val="5000"/>
+                  </a:schemeClr>
+                </a:solidFill>
+                <a:latin typeface="Aptos"/>
+              </a:rPr>
+              <a:t> to</a:t>
+            </a:r>
+            <a:endParaRPr lang="en-US" sz="1100" b="1" i="0" dirty="0">
+              <a:solidFill>
+                <a:schemeClr val="tx1">
+                  <a:lumMod val="95000"/>
+                  <a:lumOff val="5000"/>
+                </a:schemeClr>
+              </a:solidFill>
+              <a:latin typeface="Aptos"/>
+            </a:endParaRPr>
+          </a:p>
+          <a:p>
+            <a:pPr algn="ctr"/>
+            <a:r>
+              <a:rPr sz="1100" b="1" i="0" dirty="0">
+                <a:solidFill>
+                  <a:schemeClr val="tx1">
+                    <a:lumMod val="95000"/>
+                    <a:lumOff val="5000"/>
+                  </a:schemeClr>
+                </a:solidFill>
+                <a:latin typeface="Aptos"/>
+              </a:rPr>
+              <a:t> the live database.</a:t>
             </a:r>
           </a:p>
         </p:txBody>
@@ -14163,7 +14671,7 @@
         <p:spPr>
           <a:xfrm>
             <a:off x="1124712" y="4535424"/>
-            <a:ext cx="2715768" cy="320040"/>
+            <a:ext cx="2452723" cy="270843"/>
           </a:xfrm>
           <a:prstGeom prst="rect">
             <a:avLst/>
@@ -14178,7 +14686,7 @@
           <a:p>
             <a:pPr algn="l"/>
             <a:r>
-              <a:rPr sz="1350" b="1" i="0">
+              <a:rPr sz="1400" b="1" i="0" dirty="0">
                 <a:solidFill>
                   <a:srgbClr val="0A0A0A"/>
                 </a:solidFill>
@@ -14197,8 +14705,8 @@
         </p:nvSpPr>
         <p:spPr>
           <a:xfrm>
-            <a:off x="1124712" y="4937760"/>
-            <a:ext cx="2715768" cy="813815"/>
+            <a:off x="960120" y="5060329"/>
+            <a:ext cx="2955233" cy="563231"/>
           </a:xfrm>
           <a:prstGeom prst="rect">
             <a:avLst/>
@@ -14213,13 +14721,64 @@
           <a:p>
             <a:pPr algn="l"/>
             <a:r>
-              <a:rPr sz="980" b="0" i="0">
-                <a:solidFill>
-                  <a:srgbClr val="5F5F5F"/>
-                </a:solidFill>
-                <a:latin typeface="Aptos"/>
-              </a:rPr>
-              <a:t>Ten related tables organize donors, samples, researchers, tests, storage and usage information with PK/FK constraints.</a:t>
+              <a:rPr sz="1100" b="1" i="0" dirty="0">
+                <a:solidFill>
+                  <a:schemeClr val="tx1">
+                    <a:lumMod val="95000"/>
+                    <a:lumOff val="5000"/>
+                  </a:schemeClr>
+                </a:solidFill>
+                <a:latin typeface="Aptos"/>
+              </a:rPr>
+              <a:t>Ten related tables organize donors, samples, </a:t>
+            </a:r>
+            <a:endParaRPr lang="en-US" sz="1100" b="1" i="0" dirty="0">
+              <a:solidFill>
+                <a:schemeClr val="tx1">
+                  <a:lumMod val="95000"/>
+                  <a:lumOff val="5000"/>
+                </a:schemeClr>
+              </a:solidFill>
+              <a:latin typeface="Aptos"/>
+            </a:endParaRPr>
+          </a:p>
+          <a:p>
+            <a:pPr algn="l"/>
+            <a:r>
+              <a:rPr sz="1100" b="1" i="0" dirty="0">
+                <a:solidFill>
+                  <a:schemeClr val="tx1">
+                    <a:lumMod val="95000"/>
+                    <a:lumOff val="5000"/>
+                  </a:schemeClr>
+                </a:solidFill>
+                <a:latin typeface="Aptos"/>
+              </a:rPr>
+              <a:t>researchers, tests, storage and</a:t>
+            </a:r>
+            <a:endParaRPr lang="en-US" sz="1100" b="1" i="0" dirty="0">
+              <a:solidFill>
+                <a:schemeClr val="tx1">
+                  <a:lumMod val="95000"/>
+                  <a:lumOff val="5000"/>
+                </a:schemeClr>
+              </a:solidFill>
+              <a:latin typeface="Aptos"/>
+            </a:endParaRPr>
+          </a:p>
+          <a:p>
+            <a:pPr algn="l"/>
+            <a:r>
+              <a:rPr sz="1100" b="1" i="0" dirty="0">
+                <a:solidFill>
+                  <a:schemeClr val="tx1">
+                    <a:lumMod val="95000"/>
+                    <a:lumOff val="5000"/>
+                  </a:schemeClr>
+                </a:solidFill>
+                <a:latin typeface="Aptos"/>
+              </a:rPr>
+              <a:t> usage information with PK/FK constraints.</a:t>
             </a:r>
           </a:p>
         </p:txBody>
@@ -14406,7 +14965,7 @@
         <p:spPr>
           <a:xfrm>
             <a:off x="4937759" y="4535424"/>
-            <a:ext cx="2715768" cy="320040"/>
+            <a:ext cx="1737783" cy="270843"/>
           </a:xfrm>
           <a:prstGeom prst="rect">
             <a:avLst/>
@@ -14421,7 +14980,7 @@
           <a:p>
             <a:pPr algn="l"/>
             <a:r>
-              <a:rPr sz="1350" b="1" i="0">
+              <a:rPr sz="1400" b="1" i="0" dirty="0">
                 <a:solidFill>
                   <a:srgbClr val="0A0A0A"/>
                 </a:solidFill>
@@ -14440,8 +14999,8 @@
         </p:nvSpPr>
         <p:spPr>
           <a:xfrm>
-            <a:off x="4937759" y="4937760"/>
-            <a:ext cx="2715768" cy="813815"/>
+            <a:off x="4654296" y="5044054"/>
+            <a:ext cx="3051413" cy="563231"/>
           </a:xfrm>
           <a:prstGeom prst="rect">
             <a:avLst/>
@@ -14456,13 +15015,73 @@
           <a:p>
             <a:pPr algn="l"/>
             <a:r>
-              <a:rPr sz="980" b="0" i="0">
+              <a:rPr sz="1100" b="1" i="0" dirty="0">
+                <a:solidFill>
+                  <a:schemeClr val="tx1">
+                    <a:lumMod val="95000"/>
+                    <a:lumOff val="5000"/>
+                  </a:schemeClr>
+                </a:solidFill>
+                <a:latin typeface="Aptos"/>
+              </a:rPr>
+              <a:t>UNIQUE and NOT NULL rules,</a:t>
+            </a:r>
+            <a:endParaRPr lang="en-US" sz="1100" b="1" i="0" dirty="0">
+              <a:solidFill>
+                <a:schemeClr val="tx1">
+                  <a:lumMod val="95000"/>
+                  <a:lumOff val="5000"/>
+                </a:schemeClr>
+              </a:solidFill>
+              <a:latin typeface="Aptos"/>
+            </a:endParaRPr>
+          </a:p>
+          <a:p>
+            <a:pPr algn="l"/>
+            <a:r>
+              <a:rPr sz="1100" b="1" i="0" dirty="0">
+                <a:solidFill>
+                  <a:schemeClr val="tx1">
+                    <a:lumMod val="95000"/>
+                    <a:lumOff val="5000"/>
+                  </a:schemeClr>
+                </a:solidFill>
+                <a:latin typeface="Aptos"/>
+              </a:rPr>
+              <a:t> referential integrity, views and </a:t>
+            </a:r>
+            <a:endParaRPr lang="en-US" sz="1100" b="1" i="0" dirty="0">
+              <a:solidFill>
+                <a:schemeClr val="tx1">
+                  <a:lumMod val="95000"/>
+                  <a:lumOff val="5000"/>
+                </a:schemeClr>
+              </a:solidFill>
+              <a:latin typeface="Aptos"/>
+            </a:endParaRPr>
+          </a:p>
+          <a:p>
+            <a:pPr algn="l"/>
+            <a:r>
+              <a:rPr sz="1100" b="1" i="0" dirty="0">
+                <a:solidFill>
+                  <a:schemeClr val="tx1">
+                    <a:lumMod val="95000"/>
+                    <a:lumOff val="5000"/>
+                  </a:schemeClr>
+                </a:solidFill>
+                <a:latin typeface="Aptos"/>
+              </a:rPr>
+              <a:t>the sample-usage trigger protect the database</a:t>
+            </a:r>
+            <a:r>
+              <a:rPr sz="980" b="0" i="0" dirty="0">
                 <a:solidFill>
                   <a:srgbClr val="5F5F5F"/>
                 </a:solidFill>
                 <a:latin typeface="Aptos"/>
               </a:rPr>
-              <a:t>UNIQUE and NOT NULL rules, referential integrity, views and the sample-usage trigger protect the database.</a:t>
+              <a:t>.</a:t>
             </a:r>
           </a:p>
         </p:txBody>
@@ -14475,7 +15094,7 @@
         </p:nvSpPr>
         <p:spPr>
           <a:xfrm>
-            <a:off x="8129016" y="4370832"/>
+            <a:off x="8174736" y="4361272"/>
             <a:ext cx="3557016" cy="1508760"/>
           </a:xfrm>
           <a:prstGeom prst="roundRect">
@@ -14649,7 +15268,7 @@
         <p:spPr>
           <a:xfrm>
             <a:off x="8750808" y="4535424"/>
-            <a:ext cx="2752344" cy="320040"/>
+            <a:ext cx="1743426" cy="270843"/>
           </a:xfrm>
           <a:prstGeom prst="rect">
             <a:avLst/>
@@ -14664,7 +15283,7 @@
           <a:p>
             <a:pPr algn="l"/>
             <a:r>
-              <a:rPr sz="1350" b="1" i="0">
+              <a:rPr sz="1400" b="1" i="0" dirty="0">
                 <a:solidFill>
                   <a:srgbClr val="0A0A0A"/>
                 </a:solidFill>
@@ -14683,8 +15302,8 @@
         </p:nvSpPr>
         <p:spPr>
           <a:xfrm>
-            <a:off x="8750808" y="4937760"/>
-            <a:ext cx="2752344" cy="813815"/>
+            <a:off x="8531352" y="4975690"/>
+            <a:ext cx="2482346" cy="732508"/>
           </a:xfrm>
           <a:prstGeom prst="rect">
             <a:avLst/>
@@ -14699,13 +15318,112 @@
           <a:p>
             <a:pPr algn="l"/>
             <a:r>
-              <a:rPr sz="980" b="0" i="0">
-                <a:solidFill>
-                  <a:srgbClr val="5F5F5F"/>
-                </a:solidFill>
-                <a:latin typeface="Aptos"/>
-              </a:rPr>
-              <a:t>The connected Tkinter interface turns the database into a usable application for viewing, searching and adding donor data.</a:t>
+              <a:rPr sz="1100" b="1" i="0" dirty="0">
+                <a:solidFill>
+                  <a:schemeClr val="tx1">
+                    <a:lumMod val="95000"/>
+                    <a:lumOff val="5000"/>
+                  </a:schemeClr>
+                </a:solidFill>
+                <a:latin typeface="Aptos"/>
+              </a:rPr>
+              <a:t>The connected </a:t>
+            </a:r>
+            <a:r>
+              <a:rPr sz="1100" b="1" i="0" dirty="0" err="1">
+                <a:solidFill>
+                  <a:schemeClr val="tx1">
+                    <a:lumMod val="95000"/>
+                    <a:lumOff val="5000"/>
+                  </a:schemeClr>
+                </a:solidFill>
+                <a:latin typeface="Aptos"/>
+              </a:rPr>
+              <a:t>Tkinter</a:t>
+            </a:r>
+            <a:r>
+              <a:rPr sz="1100" b="1" i="0" dirty="0">
+                <a:solidFill>
+                  <a:schemeClr val="tx1">
+                    <a:lumMod val="95000"/>
+                    <a:lumOff val="5000"/>
+                  </a:schemeClr>
+                </a:solidFill>
+                <a:latin typeface="Aptos"/>
+              </a:rPr>
+              <a:t> interface turns</a:t>
+            </a:r>
+            <a:endParaRPr lang="en-US" sz="1100" b="1" i="0" dirty="0">
+              <a:solidFill>
+                <a:schemeClr val="tx1">
+                  <a:lumMod val="95000"/>
+                  <a:lumOff val="5000"/>
+                </a:schemeClr>
+              </a:solidFill>
+              <a:latin typeface="Aptos"/>
+            </a:endParaRPr>
+          </a:p>
+          <a:p>
+            <a:pPr algn="l"/>
+            <a:r>
+              <a:rPr sz="1100" b="1" i="0" dirty="0">
+                <a:solidFill>
+                  <a:schemeClr val="tx1">
+                    <a:lumMod val="95000"/>
+                    <a:lumOff val="5000"/>
+                  </a:schemeClr>
+                </a:solidFill>
+                <a:latin typeface="Aptos"/>
+              </a:rPr>
+              <a:t> the database into a usable </a:t>
+            </a:r>
+            <a:endParaRPr lang="en-US" sz="1100" b="1" i="0" dirty="0">
+              <a:solidFill>
+                <a:schemeClr val="tx1">
+                  <a:lumMod val="95000"/>
+                  <a:lumOff val="5000"/>
+                </a:schemeClr>
+              </a:solidFill>
+              <a:latin typeface="Aptos"/>
+            </a:endParaRPr>
+          </a:p>
+          <a:p>
+            <a:pPr algn="l"/>
+            <a:r>
+              <a:rPr sz="1100" b="1" i="0" dirty="0">
+                <a:solidFill>
+                  <a:schemeClr val="tx1">
+                    <a:lumMod val="95000"/>
+                    <a:lumOff val="5000"/>
+                  </a:schemeClr>
+                </a:solidFill>
+                <a:latin typeface="Aptos"/>
+              </a:rPr>
+              <a:t>application for viewing, searching and</a:t>
+            </a:r>
+            <a:endParaRPr lang="en-US" sz="1100" b="1" i="0" dirty="0">
+              <a:solidFill>
+                <a:schemeClr val="tx1">
+                  <a:lumMod val="95000"/>
+                  <a:lumOff val="5000"/>
+                </a:schemeClr>
+              </a:solidFill>
+              <a:latin typeface="Aptos"/>
+            </a:endParaRPr>
+          </a:p>
+          <a:p>
+            <a:pPr algn="l"/>
+            <a:r>
+              <a:rPr sz="1100" b="1" i="0" dirty="0">
+                <a:solidFill>
+                  <a:schemeClr val="tx1">
+                    <a:lumMod val="95000"/>
+                    <a:lumOff val="5000"/>
+                  </a:schemeClr>
+                </a:solidFill>
+                <a:latin typeface="Aptos"/>
+              </a:rPr>
+              <a:t> adding donor data.</a:t>
             </a:r>
           </a:p>
         </p:txBody>

</xml_diff>